<commit_message>
feat: add trained topic routing and grounded generation
</commit_message>
<xml_diff>
--- a/Umubyeyi_Presentation.pptx
+++ b/Umubyeyi_Presentation.pptx
@@ -3262,7 +3262,7 @@
               </a:defRPr>
             </a:pPr>
             <a:r>
-              <a:t>32 automated tests: unit, parameterized, boundary, invalid-input, offline and HTTP integration.</a:t>
+              <a:t>66 automated tests: unit, boundary, invalid-input, offline, HTTP, safety and evaluation integrity.</a:t>
             </a:r>
           </a:p>
           <a:p>
@@ -3277,7 +3277,7 @@
               </a:defRPr>
             </a:pPr>
             <a:r>
-              <a:t>English/RW retrieval, crisis routing, referrals, scope rejection and check-in contract verified.</a:t>
+              <a:t>Layered results: classifiers, question matching, generation quality, safety routing and latency.</a:t>
             </a:r>
           </a:p>
           <a:p>
@@ -3292,6 +3292,51 @@
               </a:defRPr>
             </a:pPr>
             <a:r>
+              <a:t>Trained topic classifier: Top-1 85.71%, Top-3 96.43%, macro-F1 85.99% on 28 controlled cases.</a:t>
+            </a:r>
+          </a:p>
+          <a:p>
+            <a:pPr>
+              <a:spcAft>
+                <a:spcPts val="1500"/>
+              </a:spcAft>
+              <a:defRPr sz="1800">
+                <a:solidFill>
+                  <a:srgbClr val="302A32"/>
+                </a:solidFill>
+              </a:defRPr>
+            </a:pPr>
+            <a:r>
+              <a:t>English retrieval: Top-1 64.29%, Top-3 92.86% on 14 controlled paraphrases.</a:t>
+            </a:r>
+          </a:p>
+          <a:p>
+            <a:pPr>
+              <a:spcAft>
+                <a:spcPts val="1500"/>
+              </a:spcAft>
+              <a:defRPr sz="1800">
+                <a:solidFill>
+                  <a:srgbClr val="302A32"/>
+                </a:solidFill>
+              </a:defRPr>
+            </a:pPr>
+            <a:r>
+              <a:t>Controlled RW retrieval and safety routing reached 100%; neither is real-user validation.</a:t>
+            </a:r>
+          </a:p>
+          <a:p>
+            <a:pPr>
+              <a:spcAft>
+                <a:spcPts val="1500"/>
+              </a:spcAft>
+              <a:defRPr sz="1800">
+                <a:solidFill>
+                  <a:srgbClr val="302A32"/>
+                </a:solidFill>
+              </a:defRPr>
+            </a:pPr>
+            <a:r>
               <a:t>Production Next.js build passes.</a:t>
             </a:r>
           </a:p>
@@ -3307,29 +3352,14 @@
               </a:defRPr>
             </a:pPr>
             <a:r>
-              <a:t>100-run fallback benchmark: retrieval median 3–4 ms; check-in median 15.3 ms.</a:t>
-            </a:r>
-          </a:p>
-          <a:p>
-            <a:pPr>
-              <a:spcAft>
-                <a:spcPts val="1500"/>
-              </a:spcAft>
-              <a:defRPr sz="1800">
-                <a:solidFill>
-                  <a:srgbClr val="302A32"/>
-                </a:solidFill>
-              </a:defRPr>
-            </a:pPr>
-            <a:r>
-              <a:t>Demo values: emotional, reformulated, Kinyarwanda, crisis, clinical, unrelated and check-in.</a:t>
+              <a:t>All cases and metrics are retained as JSON for audit and reproduction.</a:t>
             </a:r>
           </a:p>
         </p:txBody>
       </p:sp>
       <p:pic>
         <p:nvPicPr>
-          <p:cNvPr id="4" name="Picture 3" descr="conversationtest.png"/>
+          <p:cNvPr id="4" name="Picture 3" descr="layered_evaluation_summary.png"/>
           <p:cNvPicPr>
             <a:picLocks noChangeAspect="1"/>
           </p:cNvPicPr>
@@ -3344,7 +3374,7 @@
         <p:spPr>
           <a:xfrm>
             <a:off x="6446520" y="1508760"/>
-            <a:ext cx="5257800" cy="2417820"/>
+            <a:ext cx="5257800" cy="3349694"/>
           </a:xfrm>
           <a:prstGeom prst="rect">
             <a:avLst/>
@@ -3421,7 +3451,7 @@
         <p:spPr>
           <a:xfrm>
             <a:off x="731520" y="1508760"/>
-            <a:ext cx="10698480" cy="4709160"/>
+            <a:ext cx="5486400" cy="4709160"/>
           </a:xfrm>
           <a:prstGeom prst="rect">
             <a:avLst/>
@@ -3438,78 +3468,132 @@
               <a:spcAft>
                 <a:spcPts val="1500"/>
               </a:spcAft>
-              <a:defRPr sz="2000">
-                <a:solidFill>
-                  <a:srgbClr val="302A32"/>
-                </a:solidFill>
-              </a:defRPr>
-            </a:pPr>
-            <a:r>
-              <a:t>Trained here: two seven-model screening experiments and saved selected pipelines.</a:t>
-            </a:r>
-          </a:p>
-          <a:p>
-            <a:pPr>
-              <a:spcAft>
-                <a:spcPts val="1500"/>
-              </a:spcAft>
-              <a:defRPr sz="2000">
-                <a:solidFill>
-                  <a:srgbClr val="302A32"/>
-                </a:solidFill>
-              </a:defRPr>
-            </a:pPr>
-            <a:r>
-              <a:t>Built here: preprocessing, retrieval, safety policy, API integration, OOP services and interface.</a:t>
-            </a:r>
-          </a:p>
-          <a:p>
-            <a:pPr>
-              <a:spcAft>
-                <a:spcPts val="1500"/>
-              </a:spcAft>
-              <a:defRPr sz="2000">
-                <a:solidFill>
-                  <a:srgbClr val="302A32"/>
-                </a:solidFill>
-              </a:defRPr>
-            </a:pPr>
-            <a:r>
-              <a:t>Ollama model: pretrained Gemma 3 4B with project instructions; weights were not fine-tuned.</a:t>
-            </a:r>
-          </a:p>
-          <a:p>
-            <a:pPr>
-              <a:spcAft>
-                <a:spcPts val="1500"/>
-              </a:spcAft>
-              <a:defRPr sz="2000">
-                <a:solidFill>
-                  <a:srgbClr val="302A32"/>
-                </a:solidFill>
-              </a:defRPr>
-            </a:pPr>
-            <a:r>
-              <a:t>Participant rows are structured risk-factor data, not conversation examples.</a:t>
-            </a:r>
-          </a:p>
-          <a:p>
-            <a:pPr>
-              <a:spcAft>
-                <a:spcPts val="1500"/>
-              </a:spcAft>
-              <a:defRPr sz="2000">
-                <a:solidFill>
-                  <a:srgbClr val="302A32"/>
-                </a:solidFill>
-              </a:defRPr>
-            </a:pPr>
-            <a:r>
-              <a:t>A reviewed bilingual conversation corpus is required before defensible fine-tuning.</a:t>
-            </a:r>
-          </a:p>
-        </p:txBody>
-      </p:sp>
+              <a:defRPr sz="1800">
+                <a:solidFill>
+                  <a:srgbClr val="302A32"/>
+                </a:solidFill>
+              </a:defRPr>
+            </a:pPr>
+            <a:r>
+              <a:t>Trained here: two screening experiments, bilingual topic classification, and mT5 LoRA generation.</a:t>
+            </a:r>
+          </a:p>
+          <a:p>
+            <a:pPr>
+              <a:spcAft>
+                <a:spcPts val="1500"/>
+              </a:spcAft>
+              <a:defRPr sz="1800">
+                <a:solidFill>
+                  <a:srgbClr val="302A32"/>
+                </a:solidFill>
+              </a:defRPr>
+            </a:pPr>
+            <a:r>
+              <a:t>Built here: preprocessing, retrieval, safety policy, grounded Gemini integration, OOP services and interface.</a:t>
+            </a:r>
+          </a:p>
+          <a:p>
+            <a:pPr>
+              <a:spcAft>
+                <a:spcPts val="1500"/>
+              </a:spcAft>
+              <a:defRPr sz="1800">
+                <a:solidFill>
+                  <a:srgbClr val="302A32"/>
+                </a:solidFill>
+              </a:defRPr>
+            </a:pPr>
+            <a:r>
+              <a:t>mT5 LoRA: 344,064 parameters updated; validation loss 11.42 to 1.034.</a:t>
+            </a:r>
+          </a:p>
+          <a:p>
+            <a:pPr>
+              <a:spcAft>
+                <a:spcPts val="1500"/>
+              </a:spcAft>
+              <a:defRPr sz="1800">
+                <a:solidFill>
+                  <a:srgbClr val="302A32"/>
+                </a:solidFill>
+              </a:defRPr>
+            </a:pPr>
+            <a:r>
+              <a:t>Held-out topics: ROUGE-L 0.0050 to 0.4862; evidence overlap 0.0729 to 0.6687.</a:t>
+            </a:r>
+          </a:p>
+          <a:p>
+            <a:pPr>
+              <a:spcAft>
+                <a:spcPts val="1500"/>
+              </a:spcAft>
+              <a:defRPr sz="1800">
+                <a:solidFill>
+                  <a:srgbClr val="302A32"/>
+                </a:solidFill>
+              </a:defRPr>
+            </a:pPr>
+            <a:r>
+              <a:t>Topic model: 238 labelled representations, 14 classes; controlled Top-3 accuracy 96.43%.</a:t>
+            </a:r>
+          </a:p>
+          <a:p>
+            <a:pPr>
+              <a:spcAft>
+                <a:spcPts val="1500"/>
+              </a:spcAft>
+              <a:defRPr sz="1800">
+                <a:solidFill>
+                  <a:srgbClr val="302A32"/>
+                </a:solidFill>
+              </a:defRPr>
+            </a:pPr>
+            <a:r>
+              <a:t>Gemini is externally hosted and not claimed as project fine-tuning.</a:t>
+            </a:r>
+          </a:p>
+          <a:p>
+            <a:pPr>
+              <a:spcAft>
+                <a:spcPts val="1500"/>
+              </a:spcAft>
+              <a:defRPr sz="1800">
+                <a:solidFill>
+                  <a:srgbClr val="302A32"/>
+                </a:solidFill>
+              </a:defRPr>
+            </a:pPr>
+            <a:r>
+              <a:t>Ollama remains optional and prompt-configured; it is not project fine-tuning.</a:t>
+            </a:r>
+          </a:p>
+        </p:txBody>
+      </p:sp>
+      <p:pic>
+        <p:nvPicPr>
+          <p:cNvPr id="4" name="Picture 3" descr="generator_training_and_test.png"/>
+          <p:cNvPicPr>
+            <a:picLocks noChangeAspect="1"/>
+          </p:cNvPicPr>
+          <p:nvPr/>
+        </p:nvPicPr>
+        <p:blipFill>
+          <a:blip r:embed="rId2"/>
+          <a:stretch>
+            <a:fillRect/>
+          </a:stretch>
+        </p:blipFill>
+        <p:spPr>
+          <a:xfrm>
+            <a:off x="6446520" y="1508760"/>
+            <a:ext cx="5257800" cy="1937601"/>
+          </a:xfrm>
+          <a:prstGeom prst="rect">
+            <a:avLst/>
+          </a:prstGeom>
+        </p:spPr>
+      </p:pic>
     </p:spTree>
   </p:cSld>
   <p:clrMapOvr>
@@ -3634,7 +3718,37 @@
               </a:defRPr>
             </a:pPr>
             <a:r>
-              <a:t>Kinyarwanda passages require native-speaker and maternal-health review.</a:t>
+              <a:t>Strict local gate: English 9/12 accepted; Kinyarwanda 0/12, so grounded Gemini handles RW.</a:t>
+            </a:r>
+          </a:p>
+          <a:p>
+            <a:pPr>
+              <a:spcAft>
+                <a:spcPts val="1500"/>
+              </a:spcAft>
+              <a:defRPr sz="2000">
+                <a:solidFill>
+                  <a:srgbClr val="302A32"/>
+                </a:solidFill>
+              </a:defRPr>
+            </a:pPr>
+            <a:r>
+              <a:t>If Gemini is absent, times out or fails validation, the RW source passage is returned.</a:t>
+            </a:r>
+          </a:p>
+          <a:p>
+            <a:pPr>
+              <a:spcAft>
+                <a:spcPts val="1500"/>
+              </a:spcAft>
+              <a:defRPr sz="2000">
+                <a:solidFill>
+                  <a:srgbClr val="302A32"/>
+                </a:solidFill>
+              </a:defRPr>
+            </a:pPr>
+            <a:r>
+              <a:t>Topic Top-1 85.71% still exposes ambiguity; Top-3 evidence selection reached 96.43%.</a:t>
             </a:r>
           </a:p>
           <a:p>
@@ -3823,7 +3937,7 @@
               </a:defRPr>
             </a:pPr>
             <a:r>
-              <a:t>Create a reviewed bilingual conversation corpus before LoRA/QLoRA fine-tuning.</a:t>
+              <a:t>Create a larger reviewed bilingual corpus for a stronger second fine-tuning experiment.</a:t>
             </a:r>
           </a:p>
           <a:p>
@@ -4002,7 +4116,7 @@
               </a:defRPr>
             </a:pPr>
             <a:r>
-              <a:t>Live demonstration: bilingual reformulation • check-in • safety • fallback.</a:t>
+              <a:t>Live demonstration: trained topic selection • grounded Gemini • mT5 fallback • check-in • safety.</a:t>
             </a:r>
           </a:p>
         </p:txBody>

</xml_diff>

<commit_message>
Switch generator to fine-tuned BLOOMZ, add multi-turn context, and warm up user-facing copy
The wellbeing chatbot's answers now come exclusively from Umubyeyi's own
fine-tuned model (BLOOMZ-560m, LoRA on real ESConv data) instead of Gemini
generating grounded text -- Gemini is kept only for greeting small talk and
chat titles, never for wellbeing content. Conversation history is now sent
from the frontend and used by the scope router and generator, so follow-up
messages ("okay how should I handle this") stay in context instead of being
misrouted as off-topic. Also rewrites the check-in, wellness test, and
progress dashboard result copy in plainer, warmer language for non-technical
users, and adds real SHAP explainability, the EPDS-10 wellness test, and the
client-side progress dashboard.

Co-Authored-By: Claude Sonnet 5 <noreply@anthropic.com>
</commit_message>
<xml_diff>
--- a/Umubyeyi_Presentation.pptx
+++ b/Umubyeyi_Presentation.pptx
@@ -19,6 +19,7 @@
     <p:sldId id="267" r:id="rId18"/>
     <p:sldId id="268" r:id="rId19"/>
     <p:sldId id="269" r:id="rId20"/>
+    <p:sldId id="270" r:id="rId21"/>
   </p:sldIdLst>
   <p:sldSz cx="12191695" cy="6858000" type="screen4x3"/>
   <p:notesSz cx="6858000" cy="9144000"/>
@@ -3224,6 +3225,91 @@
               </a:defRPr>
             </a:pPr>
             <a:r>
+              <a:t>8. Current system architecture</a:t>
+            </a:r>
+          </a:p>
+        </p:txBody>
+      </p:sp>
+      <p:pic>
+        <p:nvPicPr>
+          <p:cNvPr id="3" name="Picture 2" descr="system_architecture_layered.png"/>
+          <p:cNvPicPr>
+            <a:picLocks noChangeAspect="1"/>
+          </p:cNvPicPr>
+          <p:nvPr/>
+        </p:nvPicPr>
+        <p:blipFill>
+          <a:blip r:embed="rId2"/>
+          <a:stretch>
+            <a:fillRect/>
+          </a:stretch>
+        </p:blipFill>
+        <p:spPr>
+          <a:xfrm>
+            <a:off x="502920" y="1143000"/>
+            <a:ext cx="11201400" cy="6266052"/>
+          </a:xfrm>
+          <a:prstGeom prst="rect">
+            <a:avLst/>
+          </a:prstGeom>
+        </p:spPr>
+      </p:pic>
+    </p:spTree>
+  </p:cSld>
+  <p:clrMapOvr>
+    <a:masterClrMapping/>
+  </p:clrMapOvr>
+</p:sld>
+</file>
+
+<file path=ppt/slides/slide11.xml><?xml version="1.0" encoding="utf-8"?>
+<p:sld xmlns:a="http://schemas.openxmlformats.org/drawingml/2006/main" xmlns:p="http://schemas.openxmlformats.org/presentationml/2006/main" xmlns:r="http://schemas.openxmlformats.org/officeDocument/2006/relationships">
+  <p:cSld>
+    <p:bg>
+      <p:bgPr>
+        <a:solidFill>
+          <a:srgbClr val="F8F1E8"/>
+        </a:solidFill>
+        <a:effectLst/>
+      </p:bgPr>
+    </p:bg>
+    <p:spTree>
+      <p:nvGrpSpPr>
+        <p:cNvPr id="1" name=""/>
+        <p:cNvGrpSpPr/>
+        <p:nvPr/>
+      </p:nvGrpSpPr>
+      <p:grpSpPr/>
+      <p:sp>
+        <p:nvSpPr>
+          <p:cNvPr id="2" name="TextBox 1"/>
+          <p:cNvSpPr txBox="1"/>
+          <p:nvPr/>
+        </p:nvSpPr>
+        <p:spPr>
+          <a:xfrm>
+            <a:off x="594360" y="320040"/>
+            <a:ext cx="10972800" cy="640080"/>
+          </a:xfrm>
+          <a:prstGeom prst="rect">
+            <a:avLst/>
+          </a:prstGeom>
+          <a:noFill/>
+        </p:spPr>
+        <p:txBody>
+          <a:bodyPr wrap="none">
+            <a:spAutoFit/>
+          </a:bodyPr>
+          <a:lstStyle/>
+          <a:p>
+            <a:pPr>
+              <a:defRPr sz="2700" b="1">
+                <a:solidFill>
+                  <a:srgbClr val="302A32"/>
+                </a:solidFill>
+              </a:defRPr>
+            </a:pPr>
+            <a:r>
               <a:t>9. Functional and testing evidence</a:t>
             </a:r>
           </a:p>
@@ -3262,7 +3348,7 @@
               </a:defRPr>
             </a:pPr>
             <a:r>
-              <a:t>66 automated tests: unit, boundary, invalid-input, offline, HTTP, safety and evaluation integrity.</a:t>
+              <a:t>67 automated tests: unit, boundary, invalid-input, offline, HTTP, safety and evaluation integrity.</a:t>
             </a:r>
           </a:p>
           <a:p>
@@ -3292,7 +3378,7 @@
               </a:defRPr>
             </a:pPr>
             <a:r>
-              <a:t>Trained topic classifier: Top-1 85.71%, Top-3 96.43%, macro-F1 85.99% on 28 controlled cases.</a:t>
+              <a:t>Trained six-class bilingual intent classifier: English Top-1 74.44%, Top-3 97.78%; Kinyarwanda Top-1 42.22%, Top-3 72.22% (90 controlled cases per language).</a:t>
             </a:r>
           </a:p>
           <a:p>
@@ -3389,219 +3475,6 @@
 </p:sld>
 </file>
 
-<file path=ppt/slides/slide11.xml><?xml version="1.0" encoding="utf-8"?>
-<p:sld xmlns:a="http://schemas.openxmlformats.org/drawingml/2006/main" xmlns:p="http://schemas.openxmlformats.org/presentationml/2006/main" xmlns:r="http://schemas.openxmlformats.org/officeDocument/2006/relationships">
-  <p:cSld>
-    <p:bg>
-      <p:bgPr>
-        <a:solidFill>
-          <a:srgbClr val="F8F1E8"/>
-        </a:solidFill>
-        <a:effectLst/>
-      </p:bgPr>
-    </p:bg>
-    <p:spTree>
-      <p:nvGrpSpPr>
-        <p:cNvPr id="1" name=""/>
-        <p:cNvGrpSpPr/>
-        <p:nvPr/>
-      </p:nvGrpSpPr>
-      <p:grpSpPr/>
-      <p:sp>
-        <p:nvSpPr>
-          <p:cNvPr id="2" name="TextBox 1"/>
-          <p:cNvSpPr txBox="1"/>
-          <p:nvPr/>
-        </p:nvSpPr>
-        <p:spPr>
-          <a:xfrm>
-            <a:off x="594360" y="320040"/>
-            <a:ext cx="10972800" cy="640080"/>
-          </a:xfrm>
-          <a:prstGeom prst="rect">
-            <a:avLst/>
-          </a:prstGeom>
-          <a:noFill/>
-        </p:spPr>
-        <p:txBody>
-          <a:bodyPr wrap="none">
-            <a:spAutoFit/>
-          </a:bodyPr>
-          <a:lstStyle/>
-          <a:p>
-            <a:pPr>
-              <a:defRPr sz="2700" b="1">
-                <a:solidFill>
-                  <a:srgbClr val="302A32"/>
-                </a:solidFill>
-              </a:defRPr>
-            </a:pPr>
-            <a:r>
-              <a:t>10. What was trained—and what was not</a:t>
-            </a:r>
-          </a:p>
-        </p:txBody>
-      </p:sp>
-      <p:sp>
-        <p:nvSpPr>
-          <p:cNvPr id="3" name="TextBox 2"/>
-          <p:cNvSpPr txBox="1"/>
-          <p:nvPr/>
-        </p:nvSpPr>
-        <p:spPr>
-          <a:xfrm>
-            <a:off x="731520" y="1508760"/>
-            <a:ext cx="5486400" cy="4709160"/>
-          </a:xfrm>
-          <a:prstGeom prst="rect">
-            <a:avLst/>
-          </a:prstGeom>
-          <a:noFill/>
-        </p:spPr>
-        <p:txBody>
-          <a:bodyPr wrap="none">
-            <a:spAutoFit/>
-          </a:bodyPr>
-          <a:lstStyle/>
-          <a:p>
-            <a:pPr>
-              <a:spcAft>
-                <a:spcPts val="1500"/>
-              </a:spcAft>
-              <a:defRPr sz="1800">
-                <a:solidFill>
-                  <a:srgbClr val="302A32"/>
-                </a:solidFill>
-              </a:defRPr>
-            </a:pPr>
-            <a:r>
-              <a:t>Trained here: two screening experiments, bilingual topic classification, and mT5 LoRA generation.</a:t>
-            </a:r>
-          </a:p>
-          <a:p>
-            <a:pPr>
-              <a:spcAft>
-                <a:spcPts val="1500"/>
-              </a:spcAft>
-              <a:defRPr sz="1800">
-                <a:solidFill>
-                  <a:srgbClr val="302A32"/>
-                </a:solidFill>
-              </a:defRPr>
-            </a:pPr>
-            <a:r>
-              <a:t>Built here: preprocessing, retrieval, safety policy, grounded Gemini integration, OOP services and interface.</a:t>
-            </a:r>
-          </a:p>
-          <a:p>
-            <a:pPr>
-              <a:spcAft>
-                <a:spcPts val="1500"/>
-              </a:spcAft>
-              <a:defRPr sz="1800">
-                <a:solidFill>
-                  <a:srgbClr val="302A32"/>
-                </a:solidFill>
-              </a:defRPr>
-            </a:pPr>
-            <a:r>
-              <a:t>mT5 LoRA: 344,064 parameters updated; validation loss 11.42 to 1.034.</a:t>
-            </a:r>
-          </a:p>
-          <a:p>
-            <a:pPr>
-              <a:spcAft>
-                <a:spcPts val="1500"/>
-              </a:spcAft>
-              <a:defRPr sz="1800">
-                <a:solidFill>
-                  <a:srgbClr val="302A32"/>
-                </a:solidFill>
-              </a:defRPr>
-            </a:pPr>
-            <a:r>
-              <a:t>Held-out topics: ROUGE-L 0.0050 to 0.4862; evidence overlap 0.0729 to 0.6687.</a:t>
-            </a:r>
-          </a:p>
-          <a:p>
-            <a:pPr>
-              <a:spcAft>
-                <a:spcPts val="1500"/>
-              </a:spcAft>
-              <a:defRPr sz="1800">
-                <a:solidFill>
-                  <a:srgbClr val="302A32"/>
-                </a:solidFill>
-              </a:defRPr>
-            </a:pPr>
-            <a:r>
-              <a:t>Topic model: 238 labelled representations, 14 classes; controlled Top-3 accuracy 96.43%.</a:t>
-            </a:r>
-          </a:p>
-          <a:p>
-            <a:pPr>
-              <a:spcAft>
-                <a:spcPts val="1500"/>
-              </a:spcAft>
-              <a:defRPr sz="1800">
-                <a:solidFill>
-                  <a:srgbClr val="302A32"/>
-                </a:solidFill>
-              </a:defRPr>
-            </a:pPr>
-            <a:r>
-              <a:t>Gemini is externally hosted and not claimed as project fine-tuning.</a:t>
-            </a:r>
-          </a:p>
-          <a:p>
-            <a:pPr>
-              <a:spcAft>
-                <a:spcPts val="1500"/>
-              </a:spcAft>
-              <a:defRPr sz="1800">
-                <a:solidFill>
-                  <a:srgbClr val="302A32"/>
-                </a:solidFill>
-              </a:defRPr>
-            </a:pPr>
-            <a:r>
-              <a:t>Ollama remains optional and prompt-configured; it is not project fine-tuning.</a:t>
-            </a:r>
-          </a:p>
-        </p:txBody>
-      </p:sp>
-      <p:pic>
-        <p:nvPicPr>
-          <p:cNvPr id="4" name="Picture 3" descr="generator_training_and_test.png"/>
-          <p:cNvPicPr>
-            <a:picLocks noChangeAspect="1"/>
-          </p:cNvPicPr>
-          <p:nvPr/>
-        </p:nvPicPr>
-        <p:blipFill>
-          <a:blip r:embed="rId2"/>
-          <a:stretch>
-            <a:fillRect/>
-          </a:stretch>
-        </p:blipFill>
-        <p:spPr>
-          <a:xfrm>
-            <a:off x="6446520" y="1508760"/>
-            <a:ext cx="5257800" cy="1937601"/>
-          </a:xfrm>
-          <a:prstGeom prst="rect">
-            <a:avLst/>
-          </a:prstGeom>
-        </p:spPr>
-      </p:pic>
-    </p:spTree>
-  </p:cSld>
-  <p:clrMapOvr>
-    <a:masterClrMapping/>
-  </p:clrMapOvr>
-</p:sld>
-</file>
-
 <file path=ppt/slides/slide12.xml><?xml version="1.0" encoding="utf-8"?>
 <p:sld xmlns:a="http://schemas.openxmlformats.org/drawingml/2006/main" xmlns:p="http://schemas.openxmlformats.org/presentationml/2006/main" xmlns:r="http://schemas.openxmlformats.org/officeDocument/2006/relationships">
   <p:cSld>
@@ -3650,7 +3523,7 @@
               </a:defRPr>
             </a:pPr>
             <a:r>
-              <a:t>11. Results, limitations and real-world validity</a:t>
+              <a:t>10. What was trained—and what was not</a:t>
             </a:r>
           </a:p>
         </p:txBody>
@@ -3664,7 +3537,7 @@
         <p:spPr>
           <a:xfrm>
             <a:off x="731520" y="1508760"/>
-            <a:ext cx="10698480" cy="4709160"/>
+            <a:ext cx="5486400" cy="4709160"/>
           </a:xfrm>
           <a:prstGeom prst="rect">
             <a:avLst/>
@@ -3681,108 +3554,132 @@
               <a:spcAft>
                 <a:spcPts val="1500"/>
               </a:spcAft>
-              <a:defRPr sz="2000">
-                <a:solidFill>
-                  <a:srgbClr val="302A32"/>
-                </a:solidFill>
-              </a:defRPr>
-            </a:pPr>
-            <a:r>
-              <a:t>Technically functioning prototype with held-out model evaluation and reproducible evidence.</a:t>
-            </a:r>
-          </a:p>
-          <a:p>
-            <a:pPr>
-              <a:spcAft>
-                <a:spcPts val="1500"/>
-              </a:spcAft>
-              <a:defRPr sz="2000">
-                <a:solidFill>
-                  <a:srgbClr val="302A32"/>
-                </a:solidFill>
-              </a:defRPr>
-            </a:pPr>
-            <a:r>
-              <a:t>No clinical diagnosis, calibration or validation for Rwanda is claimed.</a:t>
-            </a:r>
-          </a:p>
-          <a:p>
-            <a:pPr>
-              <a:spcAft>
-                <a:spcPts val="1500"/>
-              </a:spcAft>
-              <a:defRPr sz="2000">
-                <a:solidFill>
-                  <a:srgbClr val="302A32"/>
-                </a:solidFill>
-              </a:defRPr>
-            </a:pPr>
-            <a:r>
-              <a:t>Strict local gate: English 9/12 accepted; Kinyarwanda 0/12, so grounded Gemini handles RW.</a:t>
-            </a:r>
-          </a:p>
-          <a:p>
-            <a:pPr>
-              <a:spcAft>
-                <a:spcPts val="1500"/>
-              </a:spcAft>
-              <a:defRPr sz="2000">
-                <a:solidFill>
-                  <a:srgbClr val="302A32"/>
-                </a:solidFill>
-              </a:defRPr>
-            </a:pPr>
-            <a:r>
-              <a:t>If Gemini is absent, times out or fails validation, the RW source passage is returned.</a:t>
-            </a:r>
-          </a:p>
-          <a:p>
-            <a:pPr>
-              <a:spcAft>
-                <a:spcPts val="1500"/>
-              </a:spcAft>
-              <a:defRPr sz="2000">
-                <a:solidFill>
-                  <a:srgbClr val="302A32"/>
-                </a:solidFill>
-              </a:defRPr>
-            </a:pPr>
-            <a:r>
-              <a:t>Topic Top-1 85.71% still exposes ambiguity; Top-3 evidence selection reached 96.43%.</a:t>
-            </a:r>
-          </a:p>
-          <a:p>
-            <a:pPr>
-              <a:spcAft>
-                <a:spcPts val="1500"/>
-              </a:spcAft>
-              <a:defRPr sz="2000">
-                <a:solidFill>
-                  <a:srgbClr val="302A32"/>
-                </a:solidFill>
-              </a:defRPr>
-            </a:pPr>
-            <a:r>
-              <a:t>No formal field study with postpartum mothers has yet been completed.</a:t>
-            </a:r>
-          </a:p>
-          <a:p>
-            <a:pPr>
-              <a:spcAft>
-                <a:spcPts val="1500"/>
-              </a:spcAft>
-              <a:defRPr sz="2000">
-                <a:solidFill>
-                  <a:srgbClr val="302A32"/>
-                </a:solidFill>
-              </a:defRPr>
-            </a:pPr>
-            <a:r>
-              <a:t>Safety rules and retrieval reduce risk but do not replace professional support.</a:t>
-            </a:r>
-          </a:p>
-        </p:txBody>
-      </p:sp>
+              <a:defRPr sz="1800">
+                <a:solidFill>
+                  <a:srgbClr val="302A32"/>
+                </a:solidFill>
+              </a:defRPr>
+            </a:pPr>
+            <a:r>
+              <a:t>Trained here: two screening experiments, bilingual intent classification, and two LoRA generators.</a:t>
+            </a:r>
+          </a:p>
+          <a:p>
+            <a:pPr>
+              <a:spcAft>
+                <a:spcPts val="1500"/>
+              </a:spcAft>
+              <a:defRPr sz="1800">
+                <a:solidFill>
+                  <a:srgbClr val="302A32"/>
+                </a:solidFill>
+              </a:defRPr>
+            </a:pPr>
+            <a:r>
+              <a:t>Built here: preprocessing, retrieval, safety policy, grounded Gemini integration, OOP services and interface.</a:t>
+            </a:r>
+          </a:p>
+          <a:p>
+            <a:pPr>
+              <a:spcAft>
+                <a:spcPts val="1500"/>
+              </a:spcAft>
+              <a:defRPr sz="1800">
+                <a:solidFill>
+                  <a:srgbClr val="302A32"/>
+                </a:solidFill>
+              </a:defRPr>
+            </a:pPr>
+            <a:r>
+              <a:t>mT5-small LoRA (deployed): 344,064 parameters updated; validation loss 4.36 to 4.18 over 3 epochs.</a:t>
+            </a:r>
+          </a:p>
+          <a:p>
+            <a:pPr>
+              <a:spcAft>
+                <a:spcPts val="1500"/>
+              </a:spcAft>
+              <a:defRPr sz="1800">
+                <a:solidFill>
+                  <a:srgbClr val="302A32"/>
+                </a:solidFill>
+              </a:defRPr>
+            </a:pPr>
+            <a:r>
+              <a:t>flan-T5-small LoRA (comparison only, not deployed): same LoRA config; validation loss 2.95 to 2.92.</a:t>
+            </a:r>
+          </a:p>
+          <a:p>
+            <a:pPr>
+              <a:spcAft>
+                <a:spcPts val="1500"/>
+              </a:spcAft>
+              <a:defRPr sz="1800">
+                <a:solidFill>
+                  <a:srgbClr val="302A32"/>
+                </a:solidFill>
+              </a:defRPr>
+            </a:pPr>
+            <a:r>
+              <a:t>Held-out ESConv cases (100): ROUGE-L 0.000 to 0.115 (mT5-small), 0.103 to 0.142 (flan-T5-small).</a:t>
+            </a:r>
+          </a:p>
+          <a:p>
+            <a:pPr>
+              <a:spcAft>
+                <a:spcPts val="1500"/>
+              </a:spcAft>
+              <a:defRPr sz="1800">
+                <a:solidFill>
+                  <a:srgbClr val="302A32"/>
+                </a:solidFill>
+              </a:defRPr>
+            </a:pPr>
+            <a:r>
+              <a:t>7,795 real ESConv conversation examples used; AMOD returned 0 rows this run (HF gated-license fetch).</a:t>
+            </a:r>
+          </a:p>
+          <a:p>
+            <a:pPr>
+              <a:spcAft>
+                <a:spcPts val="1500"/>
+              </a:spcAft>
+              <a:defRPr sz="1800">
+                <a:solidFill>
+                  <a:srgbClr val="302A32"/>
+                </a:solidFill>
+              </a:defRPr>
+            </a:pPr>
+            <a:r>
+              <a:t>Gemini is externally hosted and not claimed as project fine-tuning.</a:t>
+            </a:r>
+          </a:p>
+        </p:txBody>
+      </p:sp>
+      <p:pic>
+        <p:nvPicPr>
+          <p:cNvPr id="4" name="Picture 3" descr="generator_training_and_test.png"/>
+          <p:cNvPicPr>
+            <a:picLocks noChangeAspect="1"/>
+          </p:cNvPicPr>
+          <p:nvPr/>
+        </p:nvPicPr>
+        <p:blipFill>
+          <a:blip r:embed="rId2"/>
+          <a:stretch>
+            <a:fillRect/>
+          </a:stretch>
+        </p:blipFill>
+        <p:spPr>
+          <a:xfrm>
+            <a:off x="6446520" y="1508760"/>
+            <a:ext cx="5257800" cy="1941729"/>
+          </a:xfrm>
+          <a:prstGeom prst="rect">
+            <a:avLst/>
+          </a:prstGeom>
+        </p:spPr>
+      </p:pic>
     </p:spTree>
   </p:cSld>
   <p:clrMapOvr>
@@ -3839,7 +3736,7 @@
               </a:defRPr>
             </a:pPr>
             <a:r>
-              <a:t>12. Recommendations and impact</a:t>
+              <a:t>11. Results, limitations and real-world validity</a:t>
             </a:r>
           </a:p>
         </p:txBody>
@@ -3877,7 +3774,7 @@
               </a:defRPr>
             </a:pPr>
             <a:r>
-              <a:t>Collect Rwanda-specific data through an ethically approved study.</a:t>
+              <a:t>Technically functioning prototype with held-out model evaluation and reproducible evidence.</a:t>
             </a:r>
           </a:p>
           <a:p>
@@ -3892,7 +3789,7 @@
               </a:defRPr>
             </a:pPr>
             <a:r>
-              <a:t>Conduct native-speaker, health-professional and usability review.</a:t>
+              <a:t>No clinical diagnosis, calibration or validation for Rwanda is claimed.</a:t>
             </a:r>
           </a:p>
           <a:p>
@@ -3907,7 +3804,7 @@
               </a:defRPr>
             </a:pPr>
             <a:r>
-              <a:t>Compare multilingual semantic embeddings with character TF-IDF.</a:t>
+              <a:t>Both fine-tuned generators are English-only; Kinyarwanda always routes to grounded Gemini or retrieval.</a:t>
             </a:r>
           </a:p>
           <a:p>
@@ -3922,7 +3819,7 @@
               </a:defRPr>
             </a:pPr>
             <a:r>
-              <a:t>Evaluate calibration, fairness, false-negative risk and resource usage.</a:t>
+              <a:t>If Gemini is absent, times out or fails validation, the RW source passage is returned.</a:t>
             </a:r>
           </a:p>
           <a:p>
@@ -3937,7 +3834,7 @@
               </a:defRPr>
             </a:pPr>
             <a:r>
-              <a:t>Create a larger reviewed bilingual corpus for a stronger second fine-tuning experiment.</a:t>
+              <a:t>Intent Top-1 74.44% (English) still exposes ambiguity; Top-3 reaches 97.78%.</a:t>
             </a:r>
           </a:p>
           <a:p>
@@ -3952,7 +3849,22 @@
               </a:defRPr>
             </a:pPr>
             <a:r>
-              <a:t>Impact: a transparent foundation for safe, locally operated maternal-support research.</a:t>
+              <a:t>No formal field study with postpartum mothers has yet been completed.</a:t>
+            </a:r>
+          </a:p>
+          <a:p>
+            <a:pPr>
+              <a:spcAft>
+                <a:spcPts val="1500"/>
+              </a:spcAft>
+              <a:defRPr sz="2000">
+                <a:solidFill>
+                  <a:srgbClr val="302A32"/>
+                </a:solidFill>
+              </a:defRPr>
+            </a:pPr>
+            <a:r>
+              <a:t>Safety rules and retrieval reduce risk but do not replace professional support.</a:t>
             </a:r>
           </a:p>
         </p:txBody>
@@ -4013,6 +3925,180 @@
               </a:defRPr>
             </a:pPr>
             <a:r>
+              <a:t>12. Recommendations and impact</a:t>
+            </a:r>
+          </a:p>
+        </p:txBody>
+      </p:sp>
+      <p:sp>
+        <p:nvSpPr>
+          <p:cNvPr id="3" name="TextBox 2"/>
+          <p:cNvSpPr txBox="1"/>
+          <p:nvPr/>
+        </p:nvSpPr>
+        <p:spPr>
+          <a:xfrm>
+            <a:off x="731520" y="1508760"/>
+            <a:ext cx="10698480" cy="4709160"/>
+          </a:xfrm>
+          <a:prstGeom prst="rect">
+            <a:avLst/>
+          </a:prstGeom>
+          <a:noFill/>
+        </p:spPr>
+        <p:txBody>
+          <a:bodyPr wrap="none">
+            <a:spAutoFit/>
+          </a:bodyPr>
+          <a:lstStyle/>
+          <a:p>
+            <a:pPr>
+              <a:spcAft>
+                <a:spcPts val="1500"/>
+              </a:spcAft>
+              <a:defRPr sz="2000">
+                <a:solidFill>
+                  <a:srgbClr val="302A32"/>
+                </a:solidFill>
+              </a:defRPr>
+            </a:pPr>
+            <a:r>
+              <a:t>Collect Rwanda-specific data through an ethically approved study.</a:t>
+            </a:r>
+          </a:p>
+          <a:p>
+            <a:pPr>
+              <a:spcAft>
+                <a:spcPts val="1500"/>
+              </a:spcAft>
+              <a:defRPr sz="2000">
+                <a:solidFill>
+                  <a:srgbClr val="302A32"/>
+                </a:solidFill>
+              </a:defRPr>
+            </a:pPr>
+            <a:r>
+              <a:t>Conduct native-speaker, health-professional and usability review.</a:t>
+            </a:r>
+          </a:p>
+          <a:p>
+            <a:pPr>
+              <a:spcAft>
+                <a:spcPts val="1500"/>
+              </a:spcAft>
+              <a:defRPr sz="2000">
+                <a:solidFill>
+                  <a:srgbClr val="302A32"/>
+                </a:solidFill>
+              </a:defRPr>
+            </a:pPr>
+            <a:r>
+              <a:t>Compare multilingual semantic embeddings with character TF-IDF.</a:t>
+            </a:r>
+          </a:p>
+          <a:p>
+            <a:pPr>
+              <a:spcAft>
+                <a:spcPts val="1500"/>
+              </a:spcAft>
+              <a:defRPr sz="2000">
+                <a:solidFill>
+                  <a:srgbClr val="302A32"/>
+                </a:solidFill>
+              </a:defRPr>
+            </a:pPr>
+            <a:r>
+              <a:t>Evaluate calibration, fairness, false-negative risk and resource usage.</a:t>
+            </a:r>
+          </a:p>
+          <a:p>
+            <a:pPr>
+              <a:spcAft>
+                <a:spcPts val="1500"/>
+              </a:spcAft>
+              <a:defRPr sz="2000">
+                <a:solidFill>
+                  <a:srgbClr val="302A32"/>
+                </a:solidFill>
+              </a:defRPr>
+            </a:pPr>
+            <a:r>
+              <a:t>Create a larger reviewed bilingual corpus for a stronger second fine-tuning experiment.</a:t>
+            </a:r>
+          </a:p>
+          <a:p>
+            <a:pPr>
+              <a:spcAft>
+                <a:spcPts val="1500"/>
+              </a:spcAft>
+              <a:defRPr sz="2000">
+                <a:solidFill>
+                  <a:srgbClr val="302A32"/>
+                </a:solidFill>
+              </a:defRPr>
+            </a:pPr>
+            <a:r>
+              <a:t>Impact: a transparent foundation for safe, locally operated maternal-support research.</a:t>
+            </a:r>
+          </a:p>
+        </p:txBody>
+      </p:sp>
+    </p:spTree>
+  </p:cSld>
+  <p:clrMapOvr>
+    <a:masterClrMapping/>
+  </p:clrMapOvr>
+</p:sld>
+</file>
+
+<file path=ppt/slides/slide15.xml><?xml version="1.0" encoding="utf-8"?>
+<p:sld xmlns:a="http://schemas.openxmlformats.org/drawingml/2006/main" xmlns:p="http://schemas.openxmlformats.org/presentationml/2006/main" xmlns:r="http://schemas.openxmlformats.org/officeDocument/2006/relationships">
+  <p:cSld>
+    <p:bg>
+      <p:bgPr>
+        <a:solidFill>
+          <a:srgbClr val="F8F1E8"/>
+        </a:solidFill>
+        <a:effectLst/>
+      </p:bgPr>
+    </p:bg>
+    <p:spTree>
+      <p:nvGrpSpPr>
+        <p:cNvPr id="1" name=""/>
+        <p:cNvGrpSpPr/>
+        <p:nvPr/>
+      </p:nvGrpSpPr>
+      <p:grpSpPr/>
+      <p:sp>
+        <p:nvSpPr>
+          <p:cNvPr id="2" name="TextBox 1"/>
+          <p:cNvSpPr txBox="1"/>
+          <p:nvPr/>
+        </p:nvSpPr>
+        <p:spPr>
+          <a:xfrm>
+            <a:off x="594360" y="320040"/>
+            <a:ext cx="10972800" cy="640080"/>
+          </a:xfrm>
+          <a:prstGeom prst="rect">
+            <a:avLst/>
+          </a:prstGeom>
+          <a:noFill/>
+        </p:spPr>
+        <p:txBody>
+          <a:bodyPr wrap="none">
+            <a:spAutoFit/>
+          </a:bodyPr>
+          <a:lstStyle/>
+          <a:p>
+            <a:pPr>
+              <a:defRPr sz="2700" b="1">
+                <a:solidFill>
+                  <a:srgbClr val="302A32"/>
+                </a:solidFill>
+              </a:defRPr>
+            </a:pPr>
+            <a:r>
               <a:t>Thank you — questions</a:t>
             </a:r>
           </a:p>
@@ -4177,7 +4263,7 @@
               </a:defRPr>
             </a:pPr>
             <a:r>
-              <a:t>1. Problem and intended user</a:t>
+              <a:t>Outline</a:t>
             </a:r>
           </a:p>
         </p:txBody>
@@ -4215,7 +4301,52 @@
               </a:defRPr>
             </a:pPr>
             <a:r>
-              <a:t>The first months after childbirth can involve sadness, anxiety, guilt, isolation and exhaustion.</a:t>
+              <a:t>Introduction</a:t>
+            </a:r>
+          </a:p>
+          <a:p>
+            <a:pPr lvl="1">
+              <a:spcAft>
+                <a:spcPts val="600"/>
+              </a:spcAft>
+              <a:defRPr sz="1600">
+                <a:solidFill>
+                  <a:srgbClr val="716874"/>
+                </a:solidFill>
+              </a:defRPr>
+            </a:pPr>
+            <a:r>
+              <a:t>Problem and intended user</a:t>
+            </a:r>
+          </a:p>
+          <a:p>
+            <a:pPr lvl="1">
+              <a:spcAft>
+                <a:spcPts val="600"/>
+              </a:spcAft>
+              <a:defRPr sz="1600">
+                <a:solidFill>
+                  <a:srgbClr val="716874"/>
+                </a:solidFill>
+              </a:defRPr>
+            </a:pPr>
+            <a:r>
+              <a:t>Literature synthesis and gap</a:t>
+            </a:r>
+          </a:p>
+          <a:p>
+            <a:pPr lvl="1">
+              <a:spcAft>
+                <a:spcPts val="600"/>
+              </a:spcAft>
+              <a:defRPr sz="1600">
+                <a:solidFill>
+                  <a:srgbClr val="716874"/>
+                </a:solidFill>
+              </a:defRPr>
+            </a:pPr>
+            <a:r>
+              <a:t>Objectives and strict scope</a:t>
             </a:r>
           </a:p>
           <a:p>
@@ -4230,7 +4361,22 @@
               </a:defRPr>
             </a:pPr>
             <a:r>
-              <a:t>Kinyarwanda-speaking mothers have limited access to culturally reviewed digital support.</a:t>
+              <a:t>Data</a:t>
+            </a:r>
+          </a:p>
+          <a:p>
+            <a:pPr lvl="1">
+              <a:spcAft>
+                <a:spcPts val="600"/>
+              </a:spcAft>
+              <a:defRPr sz="1600">
+                <a:solidFill>
+                  <a:srgbClr val="716874"/>
+                </a:solidFill>
+              </a:defRPr>
+            </a:pPr>
+            <a:r>
+              <a:t>Dataset and target</a:t>
             </a:r>
           </a:p>
           <a:p>
@@ -4245,7 +4391,52 @@
               </a:defRPr>
             </a:pPr>
             <a:r>
-              <a:t>The assistant must support the mother while refusing diagnosis, emergency care and unrelated requests.</a:t>
+              <a:t>Methodology</a:t>
+            </a:r>
+          </a:p>
+          <a:p>
+            <a:pPr lvl="1">
+              <a:spcAft>
+                <a:spcPts val="600"/>
+              </a:spcAft>
+              <a:defRPr sz="1600">
+                <a:solidFill>
+                  <a:srgbClr val="716874"/>
+                </a:solidFill>
+              </a:defRPr>
+            </a:pPr>
+            <a:r>
+              <a:t>Model selection and full-model results</a:t>
+            </a:r>
+          </a:p>
+          <a:p>
+            <a:pPr lvl="1">
+              <a:spcAft>
+                <a:spcPts val="600"/>
+              </a:spcAft>
+              <a:defRPr sz="1600">
+                <a:solidFill>
+                  <a:srgbClr val="716874"/>
+                </a:solidFill>
+              </a:defRPr>
+            </a:pPr>
+            <a:r>
+              <a:t>Practical guided check-in</a:t>
+            </a:r>
+          </a:p>
+          <a:p>
+            <a:pPr lvl="1">
+              <a:spcAft>
+                <a:spcPts val="600"/>
+              </a:spcAft>
+              <a:defRPr sz="1600">
+                <a:solidFill>
+                  <a:srgbClr val="716874"/>
+                </a:solidFill>
+              </a:defRPr>
+            </a:pPr>
+            <a:r>
+              <a:t>Current system architecture</a:t>
             </a:r>
           </a:p>
           <a:p>
@@ -4260,7 +4451,97 @@
               </a:defRPr>
             </a:pPr>
             <a:r>
-              <a:t>Mission: accessible bilingual support with transparent evidence and human referral boundaries.</a:t>
+              <a:t>Training and Testing Evidence</a:t>
+            </a:r>
+          </a:p>
+          <a:p>
+            <a:pPr lvl="1">
+              <a:spcAft>
+                <a:spcPts val="600"/>
+              </a:spcAft>
+              <a:defRPr sz="1600">
+                <a:solidFill>
+                  <a:srgbClr val="716874"/>
+                </a:solidFill>
+              </a:defRPr>
+            </a:pPr>
+            <a:r>
+              <a:t>Functional and testing evidence</a:t>
+            </a:r>
+          </a:p>
+          <a:p>
+            <a:pPr lvl="1">
+              <a:spcAft>
+                <a:spcPts val="600"/>
+              </a:spcAft>
+              <a:defRPr sz="1600">
+                <a:solidFill>
+                  <a:srgbClr val="716874"/>
+                </a:solidFill>
+              </a:defRPr>
+            </a:pPr>
+            <a:r>
+              <a:t>What was trained—and what was not</a:t>
+            </a:r>
+          </a:p>
+          <a:p>
+            <a:pPr>
+              <a:spcAft>
+                <a:spcPts val="1500"/>
+              </a:spcAft>
+              <a:defRPr sz="2000">
+                <a:solidFill>
+                  <a:srgbClr val="302A32"/>
+                </a:solidFill>
+              </a:defRPr>
+            </a:pPr>
+            <a:r>
+              <a:t>Results and Discussion</a:t>
+            </a:r>
+          </a:p>
+          <a:p>
+            <a:pPr lvl="1">
+              <a:spcAft>
+                <a:spcPts val="600"/>
+              </a:spcAft>
+              <a:defRPr sz="1600">
+                <a:solidFill>
+                  <a:srgbClr val="716874"/>
+                </a:solidFill>
+              </a:defRPr>
+            </a:pPr>
+            <a:r>
+              <a:t>Results, limitations and real-world validity</a:t>
+            </a:r>
+          </a:p>
+          <a:p>
+            <a:pPr>
+              <a:spcAft>
+                <a:spcPts val="1500"/>
+              </a:spcAft>
+              <a:defRPr sz="2000">
+                <a:solidFill>
+                  <a:srgbClr val="302A32"/>
+                </a:solidFill>
+              </a:defRPr>
+            </a:pPr>
+            <a:r>
+              <a:t>Conclusions</a:t>
+            </a:r>
+          </a:p>
+          <a:p>
+            <a:pPr lvl="1">
+              <a:spcAft>
+                <a:spcPts val="600"/>
+              </a:spcAft>
+              <a:defRPr sz="1600">
+                <a:solidFill>
+                  <a:srgbClr val="716874"/>
+                </a:solidFill>
+              </a:defRPr>
+            </a:pPr>
+            <a:r>
+              <a:t>Recommendations and impact</a:t>
             </a:r>
           </a:p>
         </p:txBody>
@@ -4321,7 +4602,7 @@
               </a:defRPr>
             </a:pPr>
             <a:r>
-              <a:t>2. Literature synthesis and gap</a:t>
+              <a:t>1. Problem and intended user</a:t>
             </a:r>
           </a:p>
         </p:txBody>
@@ -4359,7 +4640,7 @@
               </a:defRPr>
             </a:pPr>
             <a:r>
-              <a:t>Maternal chatbots mostly emphasize pregnancy, clinical tracking, or English-speaking populations.</a:t>
+              <a:t>The first months after childbirth can involve sadness, anxiety, guilt, isolation and exhaustion.</a:t>
             </a:r>
           </a:p>
           <a:p>
@@ -4374,7 +4655,7 @@
               </a:defRPr>
             </a:pPr>
             <a:r>
-              <a:t>African-language performance and reviewed Kinyarwanda resources remain limited.</a:t>
+              <a:t>Kinyarwanda-speaking mothers have limited access to culturally reviewed digital support.</a:t>
             </a:r>
           </a:p>
           <a:p>
@@ -4389,7 +4670,7 @@
               </a:defRPr>
             </a:pPr>
             <a:r>
-              <a:t>Generative flexibility creates risk when health responses are unsupported.</a:t>
+              <a:t>The assistant must support the mother while refusing diagnosis, emergency care and unrelated requests.</a:t>
             </a:r>
           </a:p>
           <a:p>
@@ -4404,7 +4685,7 @@
               </a:defRPr>
             </a:pPr>
             <a:r>
-              <a:t>Gap: bilingual postpartum emotional support combining screening research, evidence grounding and deterministic safety.</a:t>
+              <a:t>Mission: accessible bilingual support with transparent evidence and human referral boundaries.</a:t>
             </a:r>
           </a:p>
         </p:txBody>
@@ -4465,7 +4746,7 @@
               </a:defRPr>
             </a:pPr>
             <a:r>
-              <a:t>3. Objectives and strict scope</a:t>
+              <a:t>2. Literature synthesis and gap</a:t>
             </a:r>
           </a:p>
         </p:txBody>
@@ -4503,7 +4784,7 @@
               </a:defRPr>
             </a:pPr>
             <a:r>
-              <a:t>Train and compare seven classifiers on licensed postpartum participant data.</a:t>
+              <a:t>Maternal chatbots mostly emphasize pregnancy, clinical tracking, or English-speaking populations.</a:t>
             </a:r>
           </a:p>
           <a:p>
@@ -4518,7 +4799,7 @@
               </a:defRPr>
             </a:pPr>
             <a:r>
-              <a:t>Build a practical reduced-input, non-diagnostic guided check-in.</a:t>
+              <a:t>African-language performance and reviewed Kinyarwanda resources remain limited.</a:t>
             </a:r>
           </a:p>
           <a:p>
@@ -4533,7 +4814,7 @@
               </a:defRPr>
             </a:pPr>
             <a:r>
-              <a:t>Support reformulated English and Kinyarwanda emotional messages through retrieval by similarity.</a:t>
+              <a:t>Generative flexibility creates risk when health responses are unsupported.</a:t>
             </a:r>
           </a:p>
           <a:p>
@@ -4548,22 +4829,7 @@
               </a:defRPr>
             </a:pPr>
             <a:r>
-              <a:t>Place crisis, acute-health, baby-care and unrelated-topic rules before generation.</a:t>
-            </a:r>
-          </a:p>
-          <a:p>
-            <a:pPr>
-              <a:spcAft>
-                <a:spcPts val="1500"/>
-              </a:spcAft>
-              <a:defRPr sz="2000">
-                <a:solidFill>
-                  <a:srgbClr val="302A32"/>
-                </a:solidFill>
-              </a:defRPr>
-            </a:pPr>
-            <a:r>
-              <a:t>Evaluate with held-out metrics, automated tests, benchmarks and transparent limitations.</a:t>
+              <a:t>Gap: bilingual postpartum emotional support combining screening research, evidence grounding and deterministic safety.</a:t>
             </a:r>
           </a:p>
         </p:txBody>
@@ -4577,6 +4843,165 @@
 </file>
 
 <file path=ppt/slides/slide5.xml><?xml version="1.0" encoding="utf-8"?>
+<p:sld xmlns:a="http://schemas.openxmlformats.org/drawingml/2006/main" xmlns:p="http://schemas.openxmlformats.org/presentationml/2006/main" xmlns:r="http://schemas.openxmlformats.org/officeDocument/2006/relationships">
+  <p:cSld>
+    <p:bg>
+      <p:bgPr>
+        <a:solidFill>
+          <a:srgbClr val="F8F1E8"/>
+        </a:solidFill>
+        <a:effectLst/>
+      </p:bgPr>
+    </p:bg>
+    <p:spTree>
+      <p:nvGrpSpPr>
+        <p:cNvPr id="1" name=""/>
+        <p:cNvGrpSpPr/>
+        <p:nvPr/>
+      </p:nvGrpSpPr>
+      <p:grpSpPr/>
+      <p:sp>
+        <p:nvSpPr>
+          <p:cNvPr id="2" name="TextBox 1"/>
+          <p:cNvSpPr txBox="1"/>
+          <p:nvPr/>
+        </p:nvSpPr>
+        <p:spPr>
+          <a:xfrm>
+            <a:off x="594360" y="320040"/>
+            <a:ext cx="10972800" cy="640080"/>
+          </a:xfrm>
+          <a:prstGeom prst="rect">
+            <a:avLst/>
+          </a:prstGeom>
+          <a:noFill/>
+        </p:spPr>
+        <p:txBody>
+          <a:bodyPr wrap="none">
+            <a:spAutoFit/>
+          </a:bodyPr>
+          <a:lstStyle/>
+          <a:p>
+            <a:pPr>
+              <a:defRPr sz="2700" b="1">
+                <a:solidFill>
+                  <a:srgbClr val="302A32"/>
+                </a:solidFill>
+              </a:defRPr>
+            </a:pPr>
+            <a:r>
+              <a:t>3. Objectives and strict scope</a:t>
+            </a:r>
+          </a:p>
+        </p:txBody>
+      </p:sp>
+      <p:sp>
+        <p:nvSpPr>
+          <p:cNvPr id="3" name="TextBox 2"/>
+          <p:cNvSpPr txBox="1"/>
+          <p:nvPr/>
+        </p:nvSpPr>
+        <p:spPr>
+          <a:xfrm>
+            <a:off x="731520" y="1508760"/>
+            <a:ext cx="10698480" cy="4709160"/>
+          </a:xfrm>
+          <a:prstGeom prst="rect">
+            <a:avLst/>
+          </a:prstGeom>
+          <a:noFill/>
+        </p:spPr>
+        <p:txBody>
+          <a:bodyPr wrap="none">
+            <a:spAutoFit/>
+          </a:bodyPr>
+          <a:lstStyle/>
+          <a:p>
+            <a:pPr>
+              <a:spcAft>
+                <a:spcPts val="1500"/>
+              </a:spcAft>
+              <a:defRPr sz="2000">
+                <a:solidFill>
+                  <a:srgbClr val="302A32"/>
+                </a:solidFill>
+              </a:defRPr>
+            </a:pPr>
+            <a:r>
+              <a:t>Train and compare seven classifiers on licensed postpartum participant data.</a:t>
+            </a:r>
+          </a:p>
+          <a:p>
+            <a:pPr>
+              <a:spcAft>
+                <a:spcPts val="1500"/>
+              </a:spcAft>
+              <a:defRPr sz="2000">
+                <a:solidFill>
+                  <a:srgbClr val="302A32"/>
+                </a:solidFill>
+              </a:defRPr>
+            </a:pPr>
+            <a:r>
+              <a:t>Build a practical reduced-input, non-diagnostic guided check-in.</a:t>
+            </a:r>
+          </a:p>
+          <a:p>
+            <a:pPr>
+              <a:spcAft>
+                <a:spcPts val="1500"/>
+              </a:spcAft>
+              <a:defRPr sz="2000">
+                <a:solidFill>
+                  <a:srgbClr val="302A32"/>
+                </a:solidFill>
+              </a:defRPr>
+            </a:pPr>
+            <a:r>
+              <a:t>Support reformulated English and Kinyarwanda emotional messages through retrieval by similarity.</a:t>
+            </a:r>
+          </a:p>
+          <a:p>
+            <a:pPr>
+              <a:spcAft>
+                <a:spcPts val="1500"/>
+              </a:spcAft>
+              <a:defRPr sz="2000">
+                <a:solidFill>
+                  <a:srgbClr val="302A32"/>
+                </a:solidFill>
+              </a:defRPr>
+            </a:pPr>
+            <a:r>
+              <a:t>Place crisis, acute-health, baby-care and unrelated-topic rules before generation.</a:t>
+            </a:r>
+          </a:p>
+          <a:p>
+            <a:pPr>
+              <a:spcAft>
+                <a:spcPts val="1500"/>
+              </a:spcAft>
+              <a:defRPr sz="2000">
+                <a:solidFill>
+                  <a:srgbClr val="302A32"/>
+                </a:solidFill>
+              </a:defRPr>
+            </a:pPr>
+            <a:r>
+              <a:t>Evaluate with held-out metrics, automated tests, benchmarks and transparent limitations.</a:t>
+            </a:r>
+          </a:p>
+        </p:txBody>
+      </p:sp>
+    </p:spTree>
+  </p:cSld>
+  <p:clrMapOvr>
+    <a:masterClrMapping/>
+  </p:clrMapOvr>
+</p:sld>
+</file>
+
+<file path=ppt/slides/slide6.xml><?xml version="1.0" encoding="utf-8"?>
 <p:sld xmlns:a="http://schemas.openxmlformats.org/drawingml/2006/main" xmlns:p="http://schemas.openxmlformats.org/presentationml/2006/main" xmlns:r="http://schemas.openxmlformats.org/officeDocument/2006/relationships">
   <p:cSld>
     <p:bg>
@@ -4759,7 +5184,7 @@
 </p:sld>
 </file>
 
-<file path=ppt/slides/slide6.xml><?xml version="1.0" encoding="utf-8"?>
+<file path=ppt/slides/slide7.xml><?xml version="1.0" encoding="utf-8"?>
 <p:sld xmlns:a="http://schemas.openxmlformats.org/drawingml/2006/main" xmlns:p="http://schemas.openxmlformats.org/presentationml/2006/main" xmlns:r="http://schemas.openxmlformats.org/officeDocument/2006/relationships">
   <p:cSld>
     <p:bg>
@@ -4942,189 +5367,6 @@
 </p:sld>
 </file>
 
-<file path=ppt/slides/slide7.xml><?xml version="1.0" encoding="utf-8"?>
-<p:sld xmlns:a="http://schemas.openxmlformats.org/drawingml/2006/main" xmlns:p="http://schemas.openxmlformats.org/presentationml/2006/main" xmlns:r="http://schemas.openxmlformats.org/officeDocument/2006/relationships">
-  <p:cSld>
-    <p:bg>
-      <p:bgPr>
-        <a:solidFill>
-          <a:srgbClr val="F8F1E8"/>
-        </a:solidFill>
-        <a:effectLst/>
-      </p:bgPr>
-    </p:bg>
-    <p:spTree>
-      <p:nvGrpSpPr>
-        <p:cNvPr id="1" name=""/>
-        <p:cNvGrpSpPr/>
-        <p:nvPr/>
-      </p:nvGrpSpPr>
-      <p:grpSpPr/>
-      <p:sp>
-        <p:nvSpPr>
-          <p:cNvPr id="2" name="TextBox 1"/>
-          <p:cNvSpPr txBox="1"/>
-          <p:nvPr/>
-        </p:nvSpPr>
-        <p:spPr>
-          <a:xfrm>
-            <a:off x="594360" y="320040"/>
-            <a:ext cx="10972800" cy="640080"/>
-          </a:xfrm>
-          <a:prstGeom prst="rect">
-            <a:avLst/>
-          </a:prstGeom>
-          <a:noFill/>
-        </p:spPr>
-        <p:txBody>
-          <a:bodyPr wrap="none">
-            <a:spAutoFit/>
-          </a:bodyPr>
-          <a:lstStyle/>
-          <a:p>
-            <a:pPr>
-              <a:defRPr sz="2700" b="1">
-                <a:solidFill>
-                  <a:srgbClr val="302A32"/>
-                </a:solidFill>
-              </a:defRPr>
-            </a:pPr>
-            <a:r>
-              <a:t>6. Full-model results</a:t>
-            </a:r>
-          </a:p>
-        </p:txBody>
-      </p:sp>
-      <p:sp>
-        <p:nvSpPr>
-          <p:cNvPr id="3" name="TextBox 2"/>
-          <p:cNvSpPr txBox="1"/>
-          <p:nvPr/>
-        </p:nvSpPr>
-        <p:spPr>
-          <a:xfrm>
-            <a:off x="731520" y="1508760"/>
-            <a:ext cx="5486400" cy="4709160"/>
-          </a:xfrm>
-          <a:prstGeom prst="rect">
-            <a:avLst/>
-          </a:prstGeom>
-          <a:noFill/>
-        </p:spPr>
-        <p:txBody>
-          <a:bodyPr wrap="none">
-            <a:spAutoFit/>
-          </a:bodyPr>
-          <a:lstStyle/>
-          <a:p>
-            <a:pPr>
-              <a:spcAft>
-                <a:spcPts val="1500"/>
-              </a:spcAft>
-              <a:defRPr sz="1800">
-                <a:solidFill>
-                  <a:srgbClr val="302A32"/>
-                </a:solidFill>
-              </a:defRPr>
-            </a:pPr>
-            <a:r>
-              <a:t>Random Forest selected • 46 predictors.</a:t>
-            </a:r>
-          </a:p>
-          <a:p>
-            <a:pPr>
-              <a:spcAft>
-                <a:spcPts val="1500"/>
-              </a:spcAft>
-              <a:defRPr sz="1800">
-                <a:solidFill>
-                  <a:srgbClr val="302A32"/>
-                </a:solidFill>
-              </a:defRPr>
-            </a:pPr>
-            <a:r>
-              <a:t>Accuracy 0.8083 • Precision 0.7679.</a:t>
-            </a:r>
-          </a:p>
-          <a:p>
-            <a:pPr>
-              <a:spcAft>
-                <a:spcPts val="1500"/>
-              </a:spcAft>
-              <a:defRPr sz="1800">
-                <a:solidFill>
-                  <a:srgbClr val="302A32"/>
-                </a:solidFill>
-              </a:defRPr>
-            </a:pPr>
-            <a:r>
-              <a:t>Recall 0.8113 • F1 0.7890.</a:t>
-            </a:r>
-          </a:p>
-          <a:p>
-            <a:pPr>
-              <a:spcAft>
-                <a:spcPts val="1500"/>
-              </a:spcAft>
-              <a:defRPr sz="1800">
-                <a:solidFill>
-                  <a:srgbClr val="302A32"/>
-                </a:solidFill>
-              </a:defRPr>
-            </a:pPr>
-            <a:r>
-              <a:t>43/53 elevated cases detected; 10 missed; 13 false alerts.</a:t>
-            </a:r>
-          </a:p>
-          <a:p>
-            <a:pPr>
-              <a:spcAft>
-                <a:spcPts val="1500"/>
-              </a:spcAft>
-              <a:defRPr sz="1800">
-                <a:solidFill>
-                  <a:srgbClr val="302A32"/>
-                </a:solidFill>
-              </a:defRPr>
-            </a:pPr>
-            <a:r>
-              <a:t>Held-out performance is screening research, not diagnosis.</a:t>
-            </a:r>
-          </a:p>
-        </p:txBody>
-      </p:sp>
-      <p:pic>
-        <p:nvPicPr>
-          <p:cNvPr id="4" name="Picture 3" descr="06_selected_model_test_confusion_matrix.png"/>
-          <p:cNvPicPr>
-            <a:picLocks noChangeAspect="1"/>
-          </p:cNvPicPr>
-          <p:nvPr/>
-        </p:nvPicPr>
-        <p:blipFill>
-          <a:blip r:embed="rId2"/>
-          <a:stretch>
-            <a:fillRect/>
-          </a:stretch>
-        </p:blipFill>
-        <p:spPr>
-          <a:xfrm>
-            <a:off x="6446520" y="1508760"/>
-            <a:ext cx="5257800" cy="4331315"/>
-          </a:xfrm>
-          <a:prstGeom prst="rect">
-            <a:avLst/>
-          </a:prstGeom>
-        </p:spPr>
-      </p:pic>
-    </p:spTree>
-  </p:cSld>
-  <p:clrMapOvr>
-    <a:masterClrMapping/>
-  </p:clrMapOvr>
-</p:sld>
-</file>
-
 <file path=ppt/slides/slide8.xml><?xml version="1.0" encoding="utf-8"?>
 <p:sld xmlns:a="http://schemas.openxmlformats.org/drawingml/2006/main" xmlns:p="http://schemas.openxmlformats.org/presentationml/2006/main" xmlns:r="http://schemas.openxmlformats.org/officeDocument/2006/relationships">
   <p:cSld>
@@ -5173,7 +5415,7 @@
               </a:defRPr>
             </a:pPr>
             <a:r>
-              <a:t>7. Practical guided check-in</a:t>
+              <a:t>6. Full-model results</a:t>
             </a:r>
           </a:p>
         </p:txBody>
@@ -5211,7 +5453,7 @@
               </a:defRPr>
             </a:pPr>
             <a:r>
-              <a:t>Same seven algorithm families compared using 15 understandable inputs.</a:t>
+              <a:t>Random Forest selected • 46 predictors.</a:t>
             </a:r>
           </a:p>
           <a:p>
@@ -5226,7 +5468,7 @@
               </a:defRPr>
             </a:pPr>
             <a:r>
-              <a:t>Logistic Regression selected by validation F1.</a:t>
+              <a:t>Accuracy 0.8083 • Precision 0.7679.</a:t>
             </a:r>
           </a:p>
           <a:p>
@@ -5241,7 +5483,7 @@
               </a:defRPr>
             </a:pPr>
             <a:r>
-              <a:t>Accuracy 0.7667 • Precision 0.7049.</a:t>
+              <a:t>Recall 0.8113 • F1 0.7890.</a:t>
             </a:r>
           </a:p>
           <a:p>
@@ -5256,7 +5498,7 @@
               </a:defRPr>
             </a:pPr>
             <a:r>
-              <a:t>Recall 0.8113 • F1 0.7544.</a:t>
+              <a:t>43/53 elevated cases detected; 10 missed; 13 false alerts.</a:t>
             </a:r>
           </a:p>
           <a:p>
@@ -5271,7 +5513,7 @@
               </a:defRPr>
             </a:pPr>
             <a:r>
-              <a:t>Same recall as the full model, with more false alerts but much lower input burden.</a:t>
+              <a:t>Held-out performance is screening research, not diagnosis.</a:t>
             </a:r>
           </a:p>
         </p:txBody>
@@ -5356,14 +5598,112 @@
               </a:defRPr>
             </a:pPr>
             <a:r>
-              <a:t>8. Current system architecture</a:t>
+              <a:t>7. Practical guided check-in</a:t>
+            </a:r>
+          </a:p>
+        </p:txBody>
+      </p:sp>
+      <p:sp>
+        <p:nvSpPr>
+          <p:cNvPr id="3" name="TextBox 2"/>
+          <p:cNvSpPr txBox="1"/>
+          <p:nvPr/>
+        </p:nvSpPr>
+        <p:spPr>
+          <a:xfrm>
+            <a:off x="731520" y="1508760"/>
+            <a:ext cx="5486400" cy="4709160"/>
+          </a:xfrm>
+          <a:prstGeom prst="rect">
+            <a:avLst/>
+          </a:prstGeom>
+          <a:noFill/>
+        </p:spPr>
+        <p:txBody>
+          <a:bodyPr wrap="none">
+            <a:spAutoFit/>
+          </a:bodyPr>
+          <a:lstStyle/>
+          <a:p>
+            <a:pPr>
+              <a:spcAft>
+                <a:spcPts val="1500"/>
+              </a:spcAft>
+              <a:defRPr sz="1800">
+                <a:solidFill>
+                  <a:srgbClr val="302A32"/>
+                </a:solidFill>
+              </a:defRPr>
+            </a:pPr>
+            <a:r>
+              <a:t>Same seven algorithm families compared using 15 understandable inputs.</a:t>
+            </a:r>
+          </a:p>
+          <a:p>
+            <a:pPr>
+              <a:spcAft>
+                <a:spcPts val="1500"/>
+              </a:spcAft>
+              <a:defRPr sz="1800">
+                <a:solidFill>
+                  <a:srgbClr val="302A32"/>
+                </a:solidFill>
+              </a:defRPr>
+            </a:pPr>
+            <a:r>
+              <a:t>Logistic Regression selected by validation F1.</a:t>
+            </a:r>
+          </a:p>
+          <a:p>
+            <a:pPr>
+              <a:spcAft>
+                <a:spcPts val="1500"/>
+              </a:spcAft>
+              <a:defRPr sz="1800">
+                <a:solidFill>
+                  <a:srgbClr val="302A32"/>
+                </a:solidFill>
+              </a:defRPr>
+            </a:pPr>
+            <a:r>
+              <a:t>Accuracy 0.7667 • Precision 0.7049.</a:t>
+            </a:r>
+          </a:p>
+          <a:p>
+            <a:pPr>
+              <a:spcAft>
+                <a:spcPts val="1500"/>
+              </a:spcAft>
+              <a:defRPr sz="1800">
+                <a:solidFill>
+                  <a:srgbClr val="302A32"/>
+                </a:solidFill>
+              </a:defRPr>
+            </a:pPr>
+            <a:r>
+              <a:t>Recall 0.8113 • F1 0.7544.</a:t>
+            </a:r>
+          </a:p>
+          <a:p>
+            <a:pPr>
+              <a:spcAft>
+                <a:spcPts val="1500"/>
+              </a:spcAft>
+              <a:defRPr sz="1800">
+                <a:solidFill>
+                  <a:srgbClr val="302A32"/>
+                </a:solidFill>
+              </a:defRPr>
+            </a:pPr>
+            <a:r>
+              <a:t>Same recall as the full model, with more false alerts but much lower input burden.</a:t>
             </a:r>
           </a:p>
         </p:txBody>
       </p:sp>
       <p:pic>
         <p:nvPicPr>
-          <p:cNvPr id="3" name="Picture 2" descr="system_architecture_layered.png"/>
+          <p:cNvPr id="4" name="Picture 3" descr="06_selected_model_test_confusion_matrix.png"/>
           <p:cNvPicPr>
             <a:picLocks noChangeAspect="1"/>
           </p:cNvPicPr>
@@ -5377,8 +5717,8 @@
         </p:blipFill>
         <p:spPr>
           <a:xfrm>
-            <a:off x="502920" y="1143000"/>
-            <a:ext cx="11201400" cy="6266052"/>
+            <a:off x="6446520" y="1508760"/>
+            <a:ext cx="5257800" cy="4331315"/>
           </a:xfrm>
           <a:prstGeom prst="rect">
             <a:avLst/>

</xml_diff>